<commit_message>
feat(sesi-04): audit komprehensif modul 4 dasar ionic dan navigasi mobile
- Upgrade 18 berkas standalone HTML dengan .guide-box, diagram SVG 100% valid XML, dan sitasi akademik
- Buat slide_16_troubleshooting_routing_ionic.html sebagai simulator diagnosis interaktif
- Upgrade slide_17_lab_quest_04_portal_modul_ut.html (perbaikan tag typo, panduan tools, dan SVG)
- Upgrade slide_18_preview_sesi_05_layout_grid_form.html (roadmap jembatan Sesi 05 dan Tugas 2)
- Lengkapi SESI_04_Dasar_Ionic_dan_Navigasi.md dengan Quick Action Banner, 18 diagram Mermaid, dan panduan tools
- Regenerasi SESI_04_Dasar_Ionic_dan_Navigasi.pptx dengan dual-card Slide 01 dan 18/18 active hyperlinks
- Harmonisasi PANDUAN_DISKUSI_TUTON.md Sesi 4 dan katalog tabel README.md
</commit_message>
<xml_diff>
--- a/slide_presentasi/SESI_04_Dasar_Ionic_dan_Navigasi.pptx
+++ b/slide_presentasi/SESI_04_Dasar_Ionic_dan_Navigasi.pptx
@@ -3156,8 +3156,8 @@
         </p:nvSpPr>
         <p:spPr>
           <a:xfrm>
-            <a:off x="896112" y="896112"/>
-            <a:ext cx="10545775" cy="5212080"/>
+            <a:off x="896112" y="530352"/>
+            <a:ext cx="10545775" cy="5897880"/>
           </a:xfrm>
           <a:prstGeom prst="rect">
             <a:avLst/>
@@ -3199,8 +3199,8 @@
         </p:nvSpPr>
         <p:spPr>
           <a:xfrm>
-            <a:off x="822960" y="822960"/>
-            <a:ext cx="10545775" cy="5212080"/>
+            <a:off x="822960" y="457200"/>
+            <a:ext cx="10545775" cy="5897880"/>
           </a:xfrm>
           <a:prstGeom prst="rect">
             <a:avLst/>
@@ -3244,8 +3244,8 @@
         </p:nvSpPr>
         <p:spPr>
           <a:xfrm>
-            <a:off x="1280160" y="1188720"/>
-            <a:ext cx="9601200" cy="4389120"/>
+            <a:off x="1097280" y="594360"/>
+            <a:ext cx="9997135" cy="1371600"/>
           </a:xfrm>
           <a:prstGeom prst="rect">
             <a:avLst/>
@@ -3260,9 +3260,9 @@
           <a:p>
             <a:pPr>
               <a:spcAft>
-                <a:spcPts val="1600"/>
+                <a:spcPts val="400"/>
               </a:spcAft>
-              <a:defRPr sz="1200" b="1">
+              <a:defRPr sz="1100" b="1">
                 <a:solidFill>
                   <a:srgbClr val="000000"/>
                 </a:solidFill>
@@ -3276,9 +3276,9 @@
           <a:p>
             <a:pPr>
               <a:spcAft>
-                <a:spcPts val="1400"/>
+                <a:spcPts val="400"/>
               </a:spcAft>
-              <a:defRPr sz="2600" b="1">
+              <a:defRPr sz="2200" b="1">
                 <a:solidFill>
                   <a:srgbClr val="000000"/>
                 </a:solidFill>
@@ -3291,10 +3291,535 @@
           </a:p>
           <a:p>
             <a:pPr>
+              <a:defRPr sz="1050">
+                <a:solidFill>
+                  <a:srgbClr val="464646"/>
+                </a:solidFill>
+                <a:latin typeface="Segoe UI"/>
+              </a:defRPr>
+            </a:pPr>
+            <a:r>
+              <a:t>Mata Kuliah: Pemrograman Berbasis Perangkat Bergerak (STSI4303 / MSIM4401)</a:t>
+            </a:r>
+            <a:br/>
+            <a:r>
+              <a:t>Modul Acuan BMP: Modul 4 • Ekosistem UI Toolkit, Adaptive Styling, Stack Navigation, &amp; Master Solusi Lab Quest 04</a:t>
+            </a:r>
+          </a:p>
+        </p:txBody>
+      </p:sp>
+      <p:sp>
+        <p:nvSpPr>
+          <p:cNvPr id="6" name="Rectangle 5"/>
+          <p:cNvSpPr/>
+          <p:nvPr/>
+        </p:nvSpPr>
+        <p:spPr>
+          <a:xfrm>
+            <a:off x="1170432" y="2130552"/>
+            <a:ext cx="4864608" cy="2468880"/>
+          </a:xfrm>
+          <a:prstGeom prst="rect">
+            <a:avLst/>
+          </a:prstGeom>
+          <a:solidFill>
+            <a:srgbClr val="000000"/>
+          </a:solidFill>
+          <a:ln>
+            <a:noFill/>
+          </a:ln>
+        </p:spPr>
+        <p:style>
+          <a:lnRef idx="1">
+            <a:schemeClr val="accent1"/>
+          </a:lnRef>
+          <a:fillRef idx="3">
+            <a:schemeClr val="accent1"/>
+          </a:fillRef>
+          <a:effectRef idx="2">
+            <a:schemeClr val="accent1"/>
+          </a:effectRef>
+          <a:fontRef idx="minor">
+            <a:schemeClr val="lt1"/>
+          </a:fontRef>
+        </p:style>
+        <p:txBody>
+          <a:bodyPr rtlCol="0" anchor="ctr"/>
+          <a:lstStyle/>
+          <a:p>
+            <a:pPr algn="ctr"/>
+          </a:p>
+        </p:txBody>
+      </p:sp>
+      <p:sp>
+        <p:nvSpPr>
+          <p:cNvPr id="7" name="Rectangle 6"/>
+          <p:cNvSpPr/>
+          <p:nvPr/>
+        </p:nvSpPr>
+        <p:spPr>
+          <a:xfrm>
+            <a:off x="1097280" y="2057400"/>
+            <a:ext cx="4864608" cy="2468880"/>
+          </a:xfrm>
+          <a:prstGeom prst="rect">
+            <a:avLst/>
+          </a:prstGeom>
+          <a:solidFill>
+            <a:srgbClr val="F5F3FF"/>
+          </a:solidFill>
+          <a:ln w="31750">
+            <a:solidFill>
+              <a:srgbClr val="000000"/>
+            </a:solidFill>
+          </a:ln>
+        </p:spPr>
+        <p:style>
+          <a:lnRef idx="1">
+            <a:schemeClr val="accent1"/>
+          </a:lnRef>
+          <a:fillRef idx="3">
+            <a:schemeClr val="accent1"/>
+          </a:fillRef>
+          <a:effectRef idx="2">
+            <a:schemeClr val="accent1"/>
+          </a:effectRef>
+          <a:fontRef idx="minor">
+            <a:schemeClr val="lt1"/>
+          </a:fontRef>
+        </p:style>
+        <p:txBody>
+          <a:bodyPr rtlCol="0" anchor="ctr"/>
+          <a:lstStyle/>
+          <a:p>
+            <a:pPr algn="ctr"/>
+          </a:p>
+        </p:txBody>
+      </p:sp>
+      <p:sp>
+        <p:nvSpPr>
+          <p:cNvPr id="8" name="TextBox 7"/>
+          <p:cNvSpPr txBox="1"/>
+          <p:nvPr/>
+        </p:nvSpPr>
+        <p:spPr>
+          <a:xfrm>
+            <a:off x="1280160" y="2194560"/>
+            <a:ext cx="4498848" cy="2194560"/>
+          </a:xfrm>
+          <a:prstGeom prst="rect">
+            <a:avLst/>
+          </a:prstGeom>
+          <a:noFill/>
+        </p:spPr>
+        <p:txBody>
+          <a:bodyPr wrap="square">
+            <a:spAutoFit/>
+          </a:bodyPr>
+          <a:lstStyle/>
+          <a:p>
+            <a:pPr>
               <a:spcAft>
-                <a:spcPts val="3600"/>
+                <a:spcPts val="600"/>
               </a:spcAft>
-              <a:defRPr sz="1350">
+              <a:defRPr sz="1100" b="1">
+                <a:solidFill>
+                  <a:srgbClr val="581C87"/>
+                </a:solidFill>
+                <a:latin typeface="Segoe UI"/>
+              </a:defRPr>
+            </a:pPr>
+            <a:r>
+              <a:t>🎯 PETA KURIKULUM &amp; TARGET CAPAIAN</a:t>
+            </a:r>
+          </a:p>
+          <a:p>
+            <a:pPr>
+              <a:spcAft>
+                <a:spcPts val="400"/>
+              </a:spcAft>
+              <a:defRPr sz="950">
+                <a:solidFill>
+                  <a:srgbClr val="1E1E1E"/>
+                </a:solidFill>
+                <a:latin typeface="Segoe UI"/>
+              </a:defRPr>
+            </a:pPr>
+            <a:r>
+              <a:t>■  Transisi Pemrograman Web ke Rekayasa Mobile Multiplatform.</a:t>
+            </a:r>
+          </a:p>
+          <a:p>
+            <a:pPr>
+              <a:spcAft>
+                <a:spcPts val="400"/>
+              </a:spcAft>
+              <a:defRPr sz="950">
+                <a:solidFill>
+                  <a:srgbClr val="1E1E1E"/>
+                </a:solidFill>
+                <a:latin typeface="Segoe UI"/>
+              </a:defRPr>
+            </a:pPr>
+            <a:r>
+              <a:t>■  Integrasi Ekosistem Ionic Framework di atas pondasi Vue 3.</a:t>
+            </a:r>
+          </a:p>
+          <a:p>
+            <a:pPr>
+              <a:spcAft>
+                <a:spcPts val="400"/>
+              </a:spcAft>
+              <a:defRPr sz="950">
+                <a:solidFill>
+                  <a:srgbClr val="1E1E1E"/>
+                </a:solidFill>
+                <a:latin typeface="Segoe UI"/>
+              </a:defRPr>
+            </a:pPr>
+            <a:r>
+              <a:t>■  Standar Anatomi Layout Baku: ion-app, ion-page, &amp; ion-content.</a:t>
+            </a:r>
+          </a:p>
+          <a:p>
+            <a:pPr>
+              <a:spcAft>
+                <a:spcPts val="400"/>
+              </a:spcAft>
+              <a:defRPr sz="950">
+                <a:solidFill>
+                  <a:srgbClr val="1E1E1E"/>
+                </a:solidFill>
+                <a:latin typeface="Segoe UI"/>
+              </a:defRPr>
+            </a:pPr>
+            <a:r>
+              <a:t>■  Persiapan Menuju Sesi 05 &amp; Asesmen Resmi TUGAS TUTORIAL 2 (20%).</a:t>
+            </a:r>
+          </a:p>
+        </p:txBody>
+      </p:sp>
+      <p:sp>
+        <p:nvSpPr>
+          <p:cNvPr id="9" name="Rectangle 8"/>
+          <p:cNvSpPr/>
+          <p:nvPr/>
+        </p:nvSpPr>
+        <p:spPr>
+          <a:xfrm>
+            <a:off x="6302959" y="2130552"/>
+            <a:ext cx="4864608" cy="2468880"/>
+          </a:xfrm>
+          <a:prstGeom prst="rect">
+            <a:avLst/>
+          </a:prstGeom>
+          <a:solidFill>
+            <a:srgbClr val="000000"/>
+          </a:solidFill>
+          <a:ln>
+            <a:noFill/>
+          </a:ln>
+        </p:spPr>
+        <p:style>
+          <a:lnRef idx="1">
+            <a:schemeClr val="accent1"/>
+          </a:lnRef>
+          <a:fillRef idx="3">
+            <a:schemeClr val="accent1"/>
+          </a:fillRef>
+          <a:effectRef idx="2">
+            <a:schemeClr val="accent1"/>
+          </a:effectRef>
+          <a:fontRef idx="minor">
+            <a:schemeClr val="lt1"/>
+          </a:fontRef>
+        </p:style>
+        <p:txBody>
+          <a:bodyPr rtlCol="0" anchor="ctr"/>
+          <a:lstStyle/>
+          <a:p>
+            <a:pPr algn="ctr"/>
+          </a:p>
+        </p:txBody>
+      </p:sp>
+      <p:sp>
+        <p:nvSpPr>
+          <p:cNvPr id="10" name="Rectangle 9"/>
+          <p:cNvSpPr/>
+          <p:nvPr/>
+        </p:nvSpPr>
+        <p:spPr>
+          <a:xfrm>
+            <a:off x="6229807" y="2057400"/>
+            <a:ext cx="4864608" cy="2468880"/>
+          </a:xfrm>
+          <a:prstGeom prst="rect">
+            <a:avLst/>
+          </a:prstGeom>
+          <a:solidFill>
+            <a:srgbClr val="FEF3C7"/>
+          </a:solidFill>
+          <a:ln w="31750">
+            <a:solidFill>
+              <a:srgbClr val="000000"/>
+            </a:solidFill>
+          </a:ln>
+        </p:spPr>
+        <p:style>
+          <a:lnRef idx="1">
+            <a:schemeClr val="accent1"/>
+          </a:lnRef>
+          <a:fillRef idx="3">
+            <a:schemeClr val="accent1"/>
+          </a:fillRef>
+          <a:effectRef idx="2">
+            <a:schemeClr val="accent1"/>
+          </a:effectRef>
+          <a:fontRef idx="minor">
+            <a:schemeClr val="lt1"/>
+          </a:fontRef>
+        </p:style>
+        <p:txBody>
+          <a:bodyPr rtlCol="0" anchor="ctr"/>
+          <a:lstStyle/>
+          <a:p>
+            <a:pPr algn="ctr"/>
+          </a:p>
+        </p:txBody>
+      </p:sp>
+      <p:sp>
+        <p:nvSpPr>
+          <p:cNvPr id="11" name="TextBox 10"/>
+          <p:cNvSpPr txBox="1"/>
+          <p:nvPr/>
+        </p:nvSpPr>
+        <p:spPr>
+          <a:xfrm>
+            <a:off x="6412687" y="2194560"/>
+            <a:ext cx="4498848" cy="2194560"/>
+          </a:xfrm>
+          <a:prstGeom prst="rect">
+            <a:avLst/>
+          </a:prstGeom>
+          <a:noFill/>
+        </p:spPr>
+        <p:txBody>
+          <a:bodyPr wrap="square">
+            <a:spAutoFit/>
+          </a:bodyPr>
+          <a:lstStyle/>
+          <a:p>
+            <a:pPr>
+              <a:spcAft>
+                <a:spcPts val="600"/>
+              </a:spcAft>
+              <a:defRPr sz="1100" b="1">
+                <a:solidFill>
+                  <a:srgbClr val="92400E"/>
+                </a:solidFill>
+                <a:latin typeface="Segoe UI"/>
+              </a:defRPr>
+            </a:pPr>
+            <a:r>
+              <a:t>📱 FOKUS SESI 04: KOMPONEN UI &amp; STACK ROUTING</a:t>
+            </a:r>
+          </a:p>
+          <a:p>
+            <a:pPr>
+              <a:spcAft>
+                <a:spcPts val="400"/>
+              </a:spcAft>
+              <a:defRPr sz="950">
+                <a:solidFill>
+                  <a:srgbClr val="1E1E1E"/>
+                </a:solidFill>
+                <a:latin typeface="Segoe UI"/>
+              </a:defRPr>
+            </a:pPr>
+            <a:r>
+              <a:t>■  Adaptive Styling: Material Design (Android) vs Cupertino (iOS).</a:t>
+            </a:r>
+          </a:p>
+          <a:p>
+            <a:pPr>
+              <a:spcAft>
+                <a:spcPts val="400"/>
+              </a:spcAft>
+              <a:defRPr sz="950">
+                <a:solidFill>
+                  <a:srgbClr val="1E1E1E"/>
+                </a:solidFill>
+                <a:latin typeface="Segoe UI"/>
+              </a:defRPr>
+            </a:pPr>
+            <a:r>
+              <a:t>■  Ragam Komponen: Button, Card, Avatar, Badge, Chip, List, Ionicons.</a:t>
+            </a:r>
+          </a:p>
+          <a:p>
+            <a:pPr>
+              <a:spcAft>
+                <a:spcPts val="400"/>
+              </a:spcAft>
+              <a:defRPr sz="950">
+                <a:solidFill>
+                  <a:srgbClr val="1E1E1E"/>
+                </a:solidFill>
+                <a:latin typeface="Segoe UI"/>
+              </a:defRPr>
+            </a:pPr>
+            <a:r>
+              <a:t>■  Filosofi Stack Navigation (LIFO) &amp; Outlet &lt;ion-router-outlet&gt;.</a:t>
+            </a:r>
+          </a:p>
+          <a:p>
+            <a:pPr>
+              <a:spcAft>
+                <a:spcPts val="400"/>
+              </a:spcAft>
+              <a:defRPr sz="950">
+                <a:solidFill>
+                  <a:srgbClr val="1E1E1E"/>
+                </a:solidFill>
+                <a:latin typeface="Segoe UI"/>
+              </a:defRPr>
+            </a:pPr>
+            <a:r>
+              <a:t>■  Lifecycle Hooks: ionViewWillEnter &amp; ionViewWillLeave (0 Memory Leak).</a:t>
+            </a:r>
+          </a:p>
+        </p:txBody>
+      </p:sp>
+      <p:sp>
+        <p:nvSpPr>
+          <p:cNvPr id="12" name="Rectangle 11"/>
+          <p:cNvSpPr/>
+          <p:nvPr/>
+        </p:nvSpPr>
+        <p:spPr>
+          <a:xfrm>
+            <a:off x="1133856" y="4745736"/>
+            <a:ext cx="9997135" cy="621792"/>
+          </a:xfrm>
+          <a:prstGeom prst="rect">
+            <a:avLst/>
+          </a:prstGeom>
+          <a:solidFill>
+            <a:srgbClr val="000000"/>
+          </a:solidFill>
+          <a:ln>
+            <a:noFill/>
+          </a:ln>
+        </p:spPr>
+        <p:style>
+          <a:lnRef idx="1">
+            <a:schemeClr val="accent1"/>
+          </a:lnRef>
+          <a:fillRef idx="3">
+            <a:schemeClr val="accent1"/>
+          </a:fillRef>
+          <a:effectRef idx="2">
+            <a:schemeClr val="accent1"/>
+          </a:effectRef>
+          <a:fontRef idx="minor">
+            <a:schemeClr val="lt1"/>
+          </a:fontRef>
+        </p:style>
+        <p:txBody>
+          <a:bodyPr rtlCol="0" anchor="ctr"/>
+          <a:lstStyle/>
+          <a:p>
+            <a:pPr algn="ctr"/>
+          </a:p>
+        </p:txBody>
+      </p:sp>
+      <p:sp>
+        <p:nvSpPr>
+          <p:cNvPr id="13" name="Rectangle 12">
+            <a:hlinkClick r:id="rId2"/>
+          </p:cNvPr>
+          <p:cNvSpPr/>
+          <p:nvPr/>
+        </p:nvSpPr>
+        <p:spPr>
+          <a:xfrm>
+            <a:off x="1097280" y="4709160"/>
+            <a:ext cx="9997135" cy="621792"/>
+          </a:xfrm>
+          <a:prstGeom prst="rect">
+            <a:avLst/>
+          </a:prstGeom>
+          <a:solidFill>
+            <a:srgbClr val="FFE600"/>
+          </a:solidFill>
+          <a:ln w="25400">
+            <a:solidFill>
+              <a:srgbClr val="000000"/>
+            </a:solidFill>
+          </a:ln>
+        </p:spPr>
+        <p:style>
+          <a:lnRef idx="1">
+            <a:schemeClr val="accent1"/>
+          </a:lnRef>
+          <a:fillRef idx="3">
+            <a:schemeClr val="accent1"/>
+          </a:fillRef>
+          <a:effectRef idx="2">
+            <a:schemeClr val="accent1"/>
+          </a:effectRef>
+          <a:fontRef idx="minor">
+            <a:schemeClr val="lt1"/>
+          </a:fontRef>
+        </p:style>
+        <p:txBody>
+          <a:bodyPr rtlCol="0" anchor="ctr"/>
+          <a:lstStyle/>
+          <a:p>
+            <a:pPr algn="ctr"/>
+          </a:p>
+        </p:txBody>
+      </p:sp>
+      <p:sp>
+        <p:nvSpPr>
+          <p:cNvPr id="14" name="TextBox 13"/>
+          <p:cNvSpPr txBox="1"/>
+          <p:nvPr/>
+        </p:nvSpPr>
+        <p:spPr>
+          <a:xfrm>
+            <a:off x="1188720" y="4745736"/>
+            <a:ext cx="9814255" cy="548640"/>
+          </a:xfrm>
+          <a:prstGeom prst="rect">
+            <a:avLst/>
+          </a:prstGeom>
+          <a:noFill/>
+        </p:spPr>
+        <p:txBody>
+          <a:bodyPr wrap="square">
+            <a:spAutoFit/>
+          </a:bodyPr>
+          <a:lstStyle/>
+          <a:p>
+            <a:pPr>
+              <a:spcAft>
+                <a:spcPts val="200"/>
+              </a:spcAft>
+              <a:defRPr sz="1000" b="1">
+                <a:solidFill>
+                  <a:srgbClr val="000000"/>
+                </a:solidFill>
+                <a:latin typeface="Segoe UI"/>
+              </a:defRPr>
+            </a:pPr>
+            <a:r>
+              <a:t>▶ KLIK DI SINI UNTUK MEMBUKA BERKAS INTERAKTIF PENGENALAN EKOSISTEM IONIC (slide_01_pengenalan_ekosistem_ionic.html)</a:t>
+            </a:r>
+          </a:p>
+          <a:p>
+            <a:pPr>
+              <a:defRPr sz="850">
                 <a:solidFill>
                   <a:srgbClr val="3C3C3C"/>
                 </a:solidFill>
@@ -3302,24 +3827,7 @@
               </a:defRPr>
             </a:pPr>
             <a:r>
-              <a:t>Mata Kuliah: Pemrograman Berbasis Perangkat Bergerak (STSI4303 / MSIM4401)</a:t>
-            </a:r>
-            <a:br/>
-            <a:r>
-              <a:t>Modul Acuan BMP: Modul 4 • Ekosistem UI Toolkit, Adaptive Styling, Stack Navigation, &amp; Master Solusi Lab Quest 04</a:t>
-            </a:r>
-          </a:p>
-          <a:p>
-            <a:pPr>
-              <a:defRPr sz="1150" b="1">
-                <a:solidFill>
-                  <a:srgbClr val="000000"/>
-                </a:solidFill>
-                <a:latin typeface="Segoe UI"/>
-              </a:defRPr>
-            </a:pPr>
-            <a:r>
-              <a:t>■  Anton Prafanto, S.Kom., M.T.  ■  FAKULTAS SAINS DAN TEKNOLOGI • UNIVERSITAS TERBUKA</a:t>
+              <a:t>■ Anton Prafanto, S.Kom., M.T. ■ FAKULTAS SAINS DAN TEKNOLOGI • UNIVERSITAS TERBUKA • EKSEKUSI LANGSUNG DI GOOGLE CHROME</a:t>
             </a:r>
           </a:p>
         </p:txBody>
@@ -3554,7 +4062,7 @@
         <p:spPr>
           <a:xfrm>
             <a:off x="896112" y="1719072"/>
-            <a:ext cx="5120640" cy="4663440"/>
+            <a:ext cx="5120640" cy="4160520"/>
           </a:xfrm>
           <a:prstGeom prst="rect">
             <a:avLst/>
@@ -3597,7 +4105,7 @@
         <p:spPr>
           <a:xfrm>
             <a:off x="822960" y="1645920"/>
-            <a:ext cx="5120640" cy="4663440"/>
+            <a:ext cx="5120640" cy="4160520"/>
           </a:xfrm>
           <a:prstGeom prst="rect">
             <a:avLst/>
@@ -3723,7 +4231,7 @@
         <p:spPr>
           <a:xfrm>
             <a:off x="1051560" y="2468880"/>
-            <a:ext cx="4663440" cy="3657600"/>
+            <a:ext cx="4663440" cy="3291840"/>
           </a:xfrm>
           <a:prstGeom prst="rect">
             <a:avLst/>
@@ -3738,7 +4246,7 @@
           <a:p>
             <a:pPr>
               <a:spcAft>
-                <a:spcPts val="800"/>
+                <a:spcPts val="600"/>
               </a:spcAft>
               <a:defRPr sz="1100">
                 <a:latin typeface="Segoe UI"/>
@@ -3751,7 +4259,7 @@
           <a:p>
             <a:pPr>
               <a:spcAft>
-                <a:spcPts val="800"/>
+                <a:spcPts val="600"/>
               </a:spcAft>
               <a:defRPr sz="1100">
                 <a:latin typeface="Segoe UI"/>
@@ -3764,7 +4272,7 @@
           <a:p>
             <a:pPr>
               <a:spcAft>
-                <a:spcPts val="800"/>
+                <a:spcPts val="600"/>
               </a:spcAft>
               <a:defRPr sz="1100">
                 <a:latin typeface="Segoe UI"/>
@@ -3777,7 +4285,7 @@
           <a:p>
             <a:pPr>
               <a:spcAft>
-                <a:spcPts val="800"/>
+                <a:spcPts val="600"/>
               </a:spcAft>
               <a:defRPr sz="1100">
                 <a:latin typeface="Segoe UI"/>
@@ -3790,7 +4298,7 @@
           <a:p>
             <a:pPr>
               <a:spcAft>
-                <a:spcPts val="800"/>
+                <a:spcPts val="600"/>
               </a:spcAft>
               <a:defRPr sz="1100">
                 <a:latin typeface="Segoe UI"/>
@@ -3811,7 +4319,7 @@
         <p:spPr>
           <a:xfrm>
             <a:off x="6321247" y="1719072"/>
-            <a:ext cx="5120640" cy="4663440"/>
+            <a:ext cx="5120640" cy="4160520"/>
           </a:xfrm>
           <a:prstGeom prst="rect">
             <a:avLst/>
@@ -3854,7 +4362,7 @@
         <p:spPr>
           <a:xfrm>
             <a:off x="6248095" y="1645920"/>
-            <a:ext cx="5120640" cy="4663440"/>
+            <a:ext cx="5120640" cy="4160520"/>
           </a:xfrm>
           <a:prstGeom prst="rect">
             <a:avLst/>
@@ -3980,7 +4488,7 @@
         <p:spPr>
           <a:xfrm>
             <a:off x="6476695" y="2468880"/>
-            <a:ext cx="4663440" cy="3657600"/>
+            <a:ext cx="4663440" cy="3291840"/>
           </a:xfrm>
           <a:prstGeom prst="rect">
             <a:avLst/>
@@ -3995,7 +4503,7 @@
           <a:p>
             <a:pPr>
               <a:spcAft>
-                <a:spcPts val="800"/>
+                <a:spcPts val="600"/>
               </a:spcAft>
               <a:defRPr sz="1100">
                 <a:latin typeface="Segoe UI"/>
@@ -4008,7 +4516,7 @@
           <a:p>
             <a:pPr>
               <a:spcAft>
-                <a:spcPts val="800"/>
+                <a:spcPts val="600"/>
               </a:spcAft>
               <a:defRPr sz="1100">
                 <a:latin typeface="Segoe UI"/>
@@ -4021,7 +4529,7 @@
           <a:p>
             <a:pPr>
               <a:spcAft>
-                <a:spcPts val="800"/>
+                <a:spcPts val="600"/>
               </a:spcAft>
               <a:defRPr sz="1100">
                 <a:latin typeface="Segoe UI"/>
@@ -4034,7 +4542,7 @@
           <a:p>
             <a:pPr>
               <a:spcAft>
-                <a:spcPts val="800"/>
+                <a:spcPts val="600"/>
               </a:spcAft>
               <a:defRPr sz="1100">
                 <a:latin typeface="Segoe UI"/>
@@ -4047,7 +4555,7 @@
           <a:p>
             <a:pPr>
               <a:spcAft>
-                <a:spcPts val="800"/>
+                <a:spcPts val="600"/>
               </a:spcAft>
               <a:defRPr sz="1100">
                 <a:latin typeface="Segoe UI"/>
@@ -4055,6 +4563,89 @@
             </a:pPr>
             <a:r>
               <a:t>■  Hemat kuota: Data katalog tidak perlu di-fetch ulang dari server!</a:t>
+            </a:r>
+          </a:p>
+        </p:txBody>
+      </p:sp>
+      <p:sp>
+        <p:nvSpPr>
+          <p:cNvPr id="17" name="Rectangle 16">
+            <a:hlinkClick r:id="rId2"/>
+          </p:cNvPr>
+          <p:cNvSpPr/>
+          <p:nvPr/>
+        </p:nvSpPr>
+        <p:spPr>
+          <a:xfrm>
+            <a:off x="822960" y="5989320"/>
+            <a:ext cx="10545775" cy="384048"/>
+          </a:xfrm>
+          <a:prstGeom prst="rect">
+            <a:avLst/>
+          </a:prstGeom>
+          <a:solidFill>
+            <a:srgbClr val="FFE600"/>
+          </a:solidFill>
+          <a:ln w="19050">
+            <a:solidFill>
+              <a:srgbClr val="000000"/>
+            </a:solidFill>
+          </a:ln>
+        </p:spPr>
+        <p:style>
+          <a:lnRef idx="1">
+            <a:schemeClr val="accent1"/>
+          </a:lnRef>
+          <a:fillRef idx="3">
+            <a:schemeClr val="accent1"/>
+          </a:fillRef>
+          <a:effectRef idx="2">
+            <a:schemeClr val="accent1"/>
+          </a:effectRef>
+          <a:fontRef idx="minor">
+            <a:schemeClr val="lt1"/>
+          </a:fontRef>
+        </p:style>
+        <p:txBody>
+          <a:bodyPr rtlCol="0" anchor="ctr"/>
+          <a:lstStyle/>
+          <a:p>
+            <a:pPr algn="ctr"/>
+          </a:p>
+        </p:txBody>
+      </p:sp>
+      <p:sp>
+        <p:nvSpPr>
+          <p:cNvPr id="18" name="TextBox 17"/>
+          <p:cNvSpPr txBox="1"/>
+          <p:nvPr/>
+        </p:nvSpPr>
+        <p:spPr>
+          <a:xfrm>
+            <a:off x="822960" y="5989320"/>
+            <a:ext cx="10545775" cy="384048"/>
+          </a:xfrm>
+          <a:prstGeom prst="rect">
+            <a:avLst/>
+          </a:prstGeom>
+          <a:noFill/>
+        </p:spPr>
+        <p:txBody>
+          <a:bodyPr wrap="none">
+            <a:spAutoFit/>
+          </a:bodyPr>
+          <a:lstStyle/>
+          <a:p>
+            <a:pPr>
+              <a:defRPr sz="950" b="1">
+                <a:solidFill>
+                  <a:srgbClr val="000000"/>
+                </a:solidFill>
+                <a:latin typeface="Segoe UI"/>
+              </a:defRPr>
+            </a:pPr>
+            <a:r>
+              <a:t>▶ KLIK UNTUK MEMBUKA KODE LENGKAP (slide_10_filosofi_stack_navigation.html)</a:t>
             </a:r>
           </a:p>
         </p:txBody>
@@ -8779,7 +9370,7 @@
               </a:defRPr>
             </a:pPr>
             <a:r>
-              <a:t>// BERKAS KODE MANDIRI: slide_16_troubleshooting_routing_ionic.md</a:t>
+              <a:t>// BERKAS KODE MANDIRI: slide_16_troubleshooting_routing_ionic.html</a:t>
             </a:r>
           </a:p>
         </p:txBody>
@@ -8963,7 +9554,7 @@
               </a:defRPr>
             </a:pPr>
             <a:r>
-              <a:t>▶ KLIK UNTUK MEMBUKA KODE LENGKAP (slide_16_troubleshooting_routing_ionic.md)</a:t>
+              <a:t>▶ KLIK UNTUK MEMBUKA KODE LENGKAP (slide_16_troubleshooting_routing_ionic.html)</a:t>
             </a:r>
           </a:p>
         </p:txBody>
@@ -10051,7 +10642,7 @@
         <p:spPr>
           <a:xfrm>
             <a:off x="896112" y="1719072"/>
-            <a:ext cx="5120640" cy="2148840"/>
+            <a:ext cx="5120640" cy="1965960"/>
           </a:xfrm>
           <a:prstGeom prst="rect">
             <a:avLst/>
@@ -10094,7 +10685,7 @@
         <p:spPr>
           <a:xfrm>
             <a:off x="822960" y="1645920"/>
-            <a:ext cx="5120640" cy="2148840"/>
+            <a:ext cx="5120640" cy="1965960"/>
           </a:xfrm>
           <a:prstGeom prst="rect">
             <a:avLst/>
@@ -10220,7 +10811,7 @@
         <p:spPr>
           <a:xfrm>
             <a:off x="1005840" y="2240280"/>
-            <a:ext cx="4754880" cy="1463040"/>
+            <a:ext cx="4754880" cy="1280160"/>
           </a:xfrm>
           <a:prstGeom prst="rect">
             <a:avLst/>
@@ -10272,7 +10863,7 @@
         <p:spPr>
           <a:xfrm>
             <a:off x="6321247" y="1719072"/>
-            <a:ext cx="5120640" cy="2148840"/>
+            <a:ext cx="5120640" cy="1965960"/>
           </a:xfrm>
           <a:prstGeom prst="rect">
             <a:avLst/>
@@ -10315,7 +10906,7 @@
         <p:spPr>
           <a:xfrm>
             <a:off x="6248095" y="1645920"/>
-            <a:ext cx="5120640" cy="2148840"/>
+            <a:ext cx="5120640" cy="1965960"/>
           </a:xfrm>
           <a:prstGeom prst="rect">
             <a:avLst/>
@@ -10441,7 +11032,7 @@
         <p:spPr>
           <a:xfrm>
             <a:off x="6430975" y="2240280"/>
-            <a:ext cx="4754880" cy="1463040"/>
+            <a:ext cx="4754880" cy="1280160"/>
           </a:xfrm>
           <a:prstGeom prst="rect">
             <a:avLst/>
@@ -10492,8 +11083,8 @@
         </p:nvSpPr>
         <p:spPr>
           <a:xfrm>
-            <a:off x="896112" y="4096512"/>
-            <a:ext cx="5120640" cy="2148840"/>
+            <a:off x="896112" y="3867912"/>
+            <a:ext cx="5120640" cy="1965960"/>
           </a:xfrm>
           <a:prstGeom prst="rect">
             <a:avLst/>
@@ -10535,8 +11126,8 @@
         </p:nvSpPr>
         <p:spPr>
           <a:xfrm>
-            <a:off x="822960" y="4023360"/>
-            <a:ext cx="5120640" cy="2148840"/>
+            <a:off x="822960" y="3794760"/>
+            <a:ext cx="5120640" cy="1965960"/>
           </a:xfrm>
           <a:prstGeom prst="rect">
             <a:avLst/>
@@ -10580,7 +11171,7 @@
         </p:nvSpPr>
         <p:spPr>
           <a:xfrm>
-            <a:off x="1005840" y="4206240"/>
+            <a:off x="1005840" y="3977640"/>
             <a:ext cx="1645920" cy="365760"/>
           </a:xfrm>
           <a:prstGeom prst="rect">
@@ -10625,7 +11216,7 @@
         </p:nvSpPr>
         <p:spPr>
           <a:xfrm>
-            <a:off x="1005840" y="4206240"/>
+            <a:off x="1005840" y="3977640"/>
             <a:ext cx="1645920" cy="365760"/>
           </a:xfrm>
           <a:prstGeom prst="rect">
@@ -10661,8 +11252,8 @@
         </p:nvSpPr>
         <p:spPr>
           <a:xfrm>
-            <a:off x="1005840" y="4617720"/>
-            <a:ext cx="4754880" cy="1463040"/>
+            <a:off x="1005840" y="4389120"/>
+            <a:ext cx="4754880" cy="1280160"/>
           </a:xfrm>
           <a:prstGeom prst="rect">
             <a:avLst/>
@@ -10713,8 +11304,8 @@
         </p:nvSpPr>
         <p:spPr>
           <a:xfrm>
-            <a:off x="6321247" y="4096512"/>
-            <a:ext cx="5120640" cy="2148840"/>
+            <a:off x="6321247" y="3867912"/>
+            <a:ext cx="5120640" cy="1965960"/>
           </a:xfrm>
           <a:prstGeom prst="rect">
             <a:avLst/>
@@ -10756,8 +11347,8 @@
         </p:nvSpPr>
         <p:spPr>
           <a:xfrm>
-            <a:off x="6248095" y="4023360"/>
-            <a:ext cx="5120640" cy="2148840"/>
+            <a:off x="6248095" y="3794760"/>
+            <a:ext cx="5120640" cy="1965960"/>
           </a:xfrm>
           <a:prstGeom prst="rect">
             <a:avLst/>
@@ -10801,7 +11392,7 @@
         </p:nvSpPr>
         <p:spPr>
           <a:xfrm>
-            <a:off x="6430975" y="4206240"/>
+            <a:off x="6430975" y="3977640"/>
             <a:ext cx="1645920" cy="365760"/>
           </a:xfrm>
           <a:prstGeom prst="rect">
@@ -10846,7 +11437,7 @@
         </p:nvSpPr>
         <p:spPr>
           <a:xfrm>
-            <a:off x="6430975" y="4206240"/>
+            <a:off x="6430975" y="3977640"/>
             <a:ext cx="1645920" cy="365760"/>
           </a:xfrm>
           <a:prstGeom prst="rect">
@@ -10882,8 +11473,8 @@
         </p:nvSpPr>
         <p:spPr>
           <a:xfrm>
-            <a:off x="6430975" y="4617720"/>
-            <a:ext cx="4754880" cy="1463040"/>
+            <a:off x="6430975" y="4389120"/>
+            <a:ext cx="4754880" cy="1280160"/>
           </a:xfrm>
           <a:prstGeom prst="rect">
             <a:avLst/>
@@ -10922,6 +11513,89 @@
             </a:pPr>
             <a:r>
               <a:t>Pemberian soal resmi Tugas Tutorial 2: Studi kasus aplikasi formulir registrasi &amp; kalkulasi biaya akademik!</a:t>
+            </a:r>
+          </a:p>
+        </p:txBody>
+      </p:sp>
+      <p:sp>
+        <p:nvSpPr>
+          <p:cNvPr id="27" name="Rectangle 26">
+            <a:hlinkClick r:id="rId2"/>
+          </p:cNvPr>
+          <p:cNvSpPr/>
+          <p:nvPr/>
+        </p:nvSpPr>
+        <p:spPr>
+          <a:xfrm>
+            <a:off x="822960" y="5989320"/>
+            <a:ext cx="10545775" cy="384048"/>
+          </a:xfrm>
+          <a:prstGeom prst="rect">
+            <a:avLst/>
+          </a:prstGeom>
+          <a:solidFill>
+            <a:srgbClr val="FFE600"/>
+          </a:solidFill>
+          <a:ln w="19050">
+            <a:solidFill>
+              <a:srgbClr val="000000"/>
+            </a:solidFill>
+          </a:ln>
+        </p:spPr>
+        <p:style>
+          <a:lnRef idx="1">
+            <a:schemeClr val="accent1"/>
+          </a:lnRef>
+          <a:fillRef idx="3">
+            <a:schemeClr val="accent1"/>
+          </a:fillRef>
+          <a:effectRef idx="2">
+            <a:schemeClr val="accent1"/>
+          </a:effectRef>
+          <a:fontRef idx="minor">
+            <a:schemeClr val="lt1"/>
+          </a:fontRef>
+        </p:style>
+        <p:txBody>
+          <a:bodyPr rtlCol="0" anchor="ctr"/>
+          <a:lstStyle/>
+          <a:p>
+            <a:pPr algn="ctr"/>
+          </a:p>
+        </p:txBody>
+      </p:sp>
+      <p:sp>
+        <p:nvSpPr>
+          <p:cNvPr id="28" name="TextBox 27"/>
+          <p:cNvSpPr txBox="1"/>
+          <p:nvPr/>
+        </p:nvSpPr>
+        <p:spPr>
+          <a:xfrm>
+            <a:off x="822960" y="5989320"/>
+            <a:ext cx="10545775" cy="384048"/>
+          </a:xfrm>
+          <a:prstGeom prst="rect">
+            <a:avLst/>
+          </a:prstGeom>
+          <a:noFill/>
+        </p:spPr>
+        <p:txBody>
+          <a:bodyPr wrap="none">
+            <a:spAutoFit/>
+          </a:bodyPr>
+          <a:lstStyle/>
+          <a:p>
+            <a:pPr>
+              <a:defRPr sz="950" b="1">
+                <a:solidFill>
+                  <a:srgbClr val="000000"/>
+                </a:solidFill>
+                <a:latin typeface="Segoe UI"/>
+              </a:defRPr>
+            </a:pPr>
+            <a:r>
+              <a:t>▶ KLIK UNTUK MEMBUKA BERKAS PREVIEW SESI 05 &amp; TUGAS 2 (slide_18_preview_sesi_05_layout_grid_form.html)</a:t>
             </a:r>
           </a:p>
         </p:txBody>
@@ -11156,7 +11830,7 @@
         <p:spPr>
           <a:xfrm>
             <a:off x="896112" y="1719072"/>
-            <a:ext cx="5120640" cy="4663440"/>
+            <a:ext cx="5120640" cy="4160520"/>
           </a:xfrm>
           <a:prstGeom prst="rect">
             <a:avLst/>
@@ -11199,7 +11873,7 @@
         <p:spPr>
           <a:xfrm>
             <a:off x="822960" y="1645920"/>
-            <a:ext cx="5120640" cy="4663440"/>
+            <a:ext cx="5120640" cy="4160520"/>
           </a:xfrm>
           <a:prstGeom prst="rect">
             <a:avLst/>
@@ -11325,7 +11999,7 @@
         <p:spPr>
           <a:xfrm>
             <a:off x="1051560" y="2468880"/>
-            <a:ext cx="4663440" cy="3657600"/>
+            <a:ext cx="4663440" cy="3291840"/>
           </a:xfrm>
           <a:prstGeom prst="rect">
             <a:avLst/>
@@ -11340,7 +12014,7 @@
           <a:p>
             <a:pPr>
               <a:spcAft>
-                <a:spcPts val="800"/>
+                <a:spcPts val="600"/>
               </a:spcAft>
               <a:defRPr sz="1100">
                 <a:latin typeface="Segoe UI"/>
@@ -11353,7 +12027,7 @@
           <a:p>
             <a:pPr>
               <a:spcAft>
-                <a:spcPts val="800"/>
+                <a:spcPts val="600"/>
               </a:spcAft>
               <a:defRPr sz="1100">
                 <a:latin typeface="Segoe UI"/>
@@ -11366,7 +12040,7 @@
           <a:p>
             <a:pPr>
               <a:spcAft>
-                <a:spcPts val="800"/>
+                <a:spcPts val="600"/>
               </a:spcAft>
               <a:defRPr sz="1100">
                 <a:latin typeface="Segoe UI"/>
@@ -11379,7 +12053,7 @@
           <a:p>
             <a:pPr>
               <a:spcAft>
-                <a:spcPts val="800"/>
+                <a:spcPts val="600"/>
               </a:spcAft>
               <a:defRPr sz="1100">
                 <a:latin typeface="Segoe UI"/>
@@ -11392,7 +12066,7 @@
           <a:p>
             <a:pPr>
               <a:spcAft>
-                <a:spcPts val="800"/>
+                <a:spcPts val="600"/>
               </a:spcAft>
               <a:defRPr sz="1100">
                 <a:latin typeface="Segoe UI"/>
@@ -11413,7 +12087,7 @@
         <p:spPr>
           <a:xfrm>
             <a:off x="6321247" y="1719072"/>
-            <a:ext cx="5120640" cy="4663440"/>
+            <a:ext cx="5120640" cy="4160520"/>
           </a:xfrm>
           <a:prstGeom prst="rect">
             <a:avLst/>
@@ -11456,7 +12130,7 @@
         <p:spPr>
           <a:xfrm>
             <a:off x="6248095" y="1645920"/>
-            <a:ext cx="5120640" cy="4663440"/>
+            <a:ext cx="5120640" cy="4160520"/>
           </a:xfrm>
           <a:prstGeom prst="rect">
             <a:avLst/>
@@ -11582,7 +12256,7 @@
         <p:spPr>
           <a:xfrm>
             <a:off x="6476695" y="2468880"/>
-            <a:ext cx="4663440" cy="3657600"/>
+            <a:ext cx="4663440" cy="3291840"/>
           </a:xfrm>
           <a:prstGeom prst="rect">
             <a:avLst/>
@@ -11597,7 +12271,7 @@
           <a:p>
             <a:pPr>
               <a:spcAft>
-                <a:spcPts val="800"/>
+                <a:spcPts val="600"/>
               </a:spcAft>
               <a:defRPr sz="1100">
                 <a:latin typeface="Segoe UI"/>
@@ -11610,7 +12284,7 @@
           <a:p>
             <a:pPr>
               <a:spcAft>
-                <a:spcPts val="800"/>
+                <a:spcPts val="600"/>
               </a:spcAft>
               <a:defRPr sz="1100">
                 <a:latin typeface="Segoe UI"/>
@@ -11623,7 +12297,7 @@
           <a:p>
             <a:pPr>
               <a:spcAft>
-                <a:spcPts val="800"/>
+                <a:spcPts val="600"/>
               </a:spcAft>
               <a:defRPr sz="1100">
                 <a:latin typeface="Segoe UI"/>
@@ -11636,7 +12310,7 @@
           <a:p>
             <a:pPr>
               <a:spcAft>
-                <a:spcPts val="800"/>
+                <a:spcPts val="600"/>
               </a:spcAft>
               <a:defRPr sz="1100">
                 <a:latin typeface="Segoe UI"/>
@@ -11649,7 +12323,7 @@
           <a:p>
             <a:pPr>
               <a:spcAft>
-                <a:spcPts val="800"/>
+                <a:spcPts val="600"/>
               </a:spcAft>
               <a:defRPr sz="1100">
                 <a:latin typeface="Segoe UI"/>
@@ -11657,6 +12331,89 @@
             </a:pPr>
             <a:r>
               <a:t>■  Ikon garis tipis elegan dengan akhiran '-outline'.</a:t>
+            </a:r>
+          </a:p>
+        </p:txBody>
+      </p:sp>
+      <p:sp>
+        <p:nvSpPr>
+          <p:cNvPr id="17" name="Rectangle 16">
+            <a:hlinkClick r:id="rId2"/>
+          </p:cNvPr>
+          <p:cNvSpPr/>
+          <p:nvPr/>
+        </p:nvSpPr>
+        <p:spPr>
+          <a:xfrm>
+            <a:off x="822960" y="5989320"/>
+            <a:ext cx="10545775" cy="384048"/>
+          </a:xfrm>
+          <a:prstGeom prst="rect">
+            <a:avLst/>
+          </a:prstGeom>
+          <a:solidFill>
+            <a:srgbClr val="FFE600"/>
+          </a:solidFill>
+          <a:ln w="19050">
+            <a:solidFill>
+              <a:srgbClr val="000000"/>
+            </a:solidFill>
+          </a:ln>
+        </p:spPr>
+        <p:style>
+          <a:lnRef idx="1">
+            <a:schemeClr val="accent1"/>
+          </a:lnRef>
+          <a:fillRef idx="3">
+            <a:schemeClr val="accent1"/>
+          </a:fillRef>
+          <a:effectRef idx="2">
+            <a:schemeClr val="accent1"/>
+          </a:effectRef>
+          <a:fontRef idx="minor">
+            <a:schemeClr val="lt1"/>
+          </a:fontRef>
+        </p:style>
+        <p:txBody>
+          <a:bodyPr rtlCol="0" anchor="ctr"/>
+          <a:lstStyle/>
+          <a:p>
+            <a:pPr algn="ctr"/>
+          </a:p>
+        </p:txBody>
+      </p:sp>
+      <p:sp>
+        <p:nvSpPr>
+          <p:cNvPr id="18" name="TextBox 17"/>
+          <p:cNvSpPr txBox="1"/>
+          <p:nvPr/>
+        </p:nvSpPr>
+        <p:spPr>
+          <a:xfrm>
+            <a:off x="822960" y="5989320"/>
+            <a:ext cx="10545775" cy="384048"/>
+          </a:xfrm>
+          <a:prstGeom prst="rect">
+            <a:avLst/>
+          </a:prstGeom>
+          <a:noFill/>
+        </p:spPr>
+        <p:txBody>
+          <a:bodyPr wrap="none">
+            <a:spAutoFit/>
+          </a:bodyPr>
+          <a:lstStyle/>
+          <a:p>
+            <a:pPr>
+              <a:defRPr sz="950" b="1">
+                <a:solidFill>
+                  <a:srgbClr val="000000"/>
+                </a:solidFill>
+                <a:latin typeface="Segoe UI"/>
+              </a:defRPr>
+            </a:pPr>
+            <a:r>
+              <a:t>▶ KLIK UNTUK MEMBUKA KODE LENGKAP (slide_02_adaptive_styling_md_ios.html)</a:t>
             </a:r>
           </a:p>
         </p:txBody>

</xml_diff>